<commit_message>
Balarama/Dvivida guide: plain language, stories narrated in full
- Rewrite the guide in simple, direct spoken English; narrate every pastime
  at the length it was told (Sampati, Angada, the jumping contest, the
  rampage item by item, the provocation, the fight blow by blow)
- Same pass over README, hub tile and all 21 deck slides
- Align two citations to the class's own wording (SB 1.2; Jarasandha
  'again and again')
</commit_message>
<xml_diff>
--- a/balarama-dvivida-kb/deck.pptx
+++ b/balarama-dvivida-kb/deck.pptx
@@ -3197,7 +3197,7 @@
                 </a:solidFill>
                 <a:latin typeface="Consolas"/>
               </a:rPr>
-              <a:t>CANTO 10  ·  CHAPTER 67  ·  A CLASS IN FIRST PRINCIPLES</a:t>
+              <a:t>CANTO 10  ·  CHAPTER 67  ·  ŚRĪMAD-BHĀGAVATAM</a:t>
             </a:r>
           </a:p>
         </p:txBody>
@@ -3613,7 +3613,7 @@
                 </a:solidFill>
                 <a:latin typeface="Calibri"/>
               </a:rPr>
-              <a:t>Viśvanātha Cakravartī Ṭhākura gives the sequence in one sentence, and it reads like a causal chain because it is one. Note the order: bad association is the punishment for the offence, not its cause.</a:t>
+              <a:t>Viśvanātha Cakravartī Ṭhākura gives the whole sequence in one sentence, and every step causes the next. Watch the order carefully: bad association is the punishment for the offence, not the reason for it.</a:t>
             </a:r>
           </a:p>
         </p:txBody>
@@ -3883,7 +3883,7 @@
                 </a:solidFill>
                 <a:latin typeface="Consolas"/>
               </a:rPr>
-              <a:t>bala-abhimāna · the condition, not yet the offence</a:t>
+              <a:t>bala-abhimāna · the condition, not yet an offence</a:t>
             </a:r>
           </a:p>
         </p:txBody>
@@ -4144,7 +4144,7 @@
                 </a:solidFill>
                 <a:latin typeface="Calibri"/>
               </a:rPr>
-              <a:t>Spiritual strength reduced   </a:t>
+              <a:t>His spiritual strength is taken away   </a:t>
             </a:r>
             <a:r>
               <a:rPr sz="1000">
@@ -4153,7 +4153,7 @@
                 </a:solidFill>
                 <a:latin typeface="Consolas"/>
               </a:rPr>
-              <a:t>the reaction · not a metaphor</a:t>
+              <a:t>the reaction · this is literal</a:t>
             </a:r>
           </a:p>
         </p:txBody>
@@ -4234,7 +4234,7 @@
                 </a:solidFill>
                 <a:latin typeface="Calibri"/>
               </a:rPr>
-              <a:t>Susceptible to bad association   </a:t>
+              <a:t>Now bad association can get at him   </a:t>
             </a:r>
             <a:r>
               <a:rPr sz="1000">
@@ -4324,7 +4324,7 @@
                 </a:solidFill>
                 <a:latin typeface="Calibri"/>
               </a:rPr>
-              <a:t>Anarthas proliferate in his heart   </a:t>
+              <a:t>Unwanted things fill his heart   </a:t>
             </a:r>
             <a:r>
               <a:rPr sz="1000">
@@ -4333,7 +4333,7 @@
                 </a:solidFill>
                 <a:latin typeface="Consolas"/>
               </a:rPr>
-              <a:t>revenge · arson · sacrilege · molestation</a:t>
+              <a:t>revenge · arson · sacrilege · molesting women</a:t>
             </a:r>
           </a:p>
         </p:txBody>
@@ -4414,7 +4414,7 @@
                 </a:solidFill>
                 <a:latin typeface="Calibri"/>
               </a:rPr>
-              <a:t>Further offences, without limit   </a:t>
+              <a:t>More offences, with no bottom to it   </a:t>
             </a:r>
             <a:r>
               <a:rPr sz="1000">
@@ -4423,7 +4423,7 @@
                 </a:solidFill>
                 <a:latin typeface="Consolas"/>
               </a:rPr>
-              <a:t>the loop that has no floor</a:t>
+              <a:t>and round it goes again</a:t>
             </a:r>
           </a:p>
         </p:txBody>
@@ -4514,7 +4514,7 @@
                 </a:solidFill>
                 <a:latin typeface="Calibri"/>
               </a:rPr>
-              <a:t>Returned — brahmajyoti or Vaikuṇṭha</a:t>
+              <a:t>Back home — brahmajyoti or Vaikuṇṭha</a:t>
             </a:r>
           </a:p>
           <a:p>
@@ -4536,7 +4536,7 @@
                 </a:solidFill>
                 <a:latin typeface="Calibri"/>
               </a:rPr>
-              <a:t>Slain by Balarāma's bare hands, and thereby liberated. SB 2.7.34–35.</a:t>
+              <a:t>Killed by Balarāma's bare hands, and liberated by it. SB 2.7.34–35.</a:t>
             </a:r>
           </a:p>
         </p:txBody>
@@ -4581,7 +4581,7 @@
                 </a:solidFill>
                 <a:latin typeface="Georgia"/>
               </a:rPr>
-              <a:t>The descent was always a round trip.</a:t>
+              <a:t>He went all the way down, and he still got back.</a:t>
             </a:r>
           </a:p>
           <a:p>
@@ -4603,7 +4603,7 @@
                 </a:solidFill>
                 <a:latin typeface="Calibri"/>
               </a:rPr>
-              <a:t>The chain has exactly one voluntary entrance — the offence. After that it runs.</a:t>
+              <a:t>There is only one step on this chain that you choose — the offence. After that, it runs on its own.</a:t>
             </a:r>
           </a:p>
           <a:p>
@@ -4625,7 +4625,7 @@
                 </a:solidFill>
                 <a:latin typeface="Calibri"/>
               </a:rPr>
-              <a:t>Once spiritual strength is reduced, resisting bad association is no longer a matter of resolve — because resolve is the thing that got reduced.</a:t>
+              <a:t>Once your spiritual strength is gone, resisting bad association is not a question of willpower. Willpower is the thing that was taken away.</a:t>
             </a:r>
           </a:p>
           <a:p>
@@ -4647,7 +4647,7 @@
                 </a:solidFill>
                 <a:latin typeface="Calibri"/>
               </a:rPr>
-              <a:t>Only the first three rungs are inside anyone's control.</a:t>
+              <a:t>Only the first three steps are ones you can do anything about.</a:t>
             </a:r>
           </a:p>
         </p:txBody>
@@ -4849,7 +4849,7 @@
                 </a:solidFill>
                 <a:latin typeface="Calibri"/>
               </a:rPr>
-              <a:t>The friend who corrupted Dvivida is himself a study in the same disease — which is the quiet joke of the chapter.</a:t>
+              <a:t>The friend who ruined Dvivida had been ruined the same way himself.</a:t>
             </a:r>
           </a:p>
         </p:txBody>
@@ -4891,7 +4891,7 @@
                 </a:solidFill>
                 <a:latin typeface="Calibri"/>
               </a:rPr>
-              <a:t>— He was not born a demon.  </a:t>
+              <a:t>— He was not born a demon either.  </a:t>
             </a:r>
             <a:r>
               <a:rPr sz="1550">
@@ -4900,7 +4900,7 @@
                 </a:solidFill>
                 <a:latin typeface="Calibri"/>
               </a:rPr>
-              <a:t>He was Naraka, son of Bhūmi (the earth) and Lord Varāha. Divine parentage on both sides.</a:t>
+              <a:t>His name was Naraka. His mother was Bhūmi — the earth herself. His father was Lord Varāha. You cannot get better parents than that.</a:t>
             </a:r>
           </a:p>
           <a:p>
@@ -4919,7 +4919,7 @@
                 </a:solidFill>
                 <a:latin typeface="Calibri"/>
               </a:rPr>
-              <a:t>— He became corrupted the same way Dvivida did —  </a:t>
+              <a:t>— He went bad the same way Dvivida did —  </a:t>
             </a:r>
             <a:r>
               <a:rPr sz="1550">
@@ -4928,7 +4928,7 @@
                 </a:solidFill>
                 <a:latin typeface="Calibri"/>
               </a:rPr>
-              <a:t>through bad association. By SB 10.59 he is Narakāsura, holding 16,100 princesses in prison; their appeal reached Kṛṣṇa, and freeing them required killing him.</a:t>
+              <a:t>by bad association. By SB 10.59 he is Narakāsura, keeping 16,100 princesses locked up. They appealed to Kṛṣṇa, and to free them Kṛṣṇa had to kill him.</a:t>
             </a:r>
           </a:p>
           <a:p>
@@ -4947,7 +4947,7 @@
                 </a:solidFill>
                 <a:latin typeface="Calibri"/>
               </a:rPr>
-              <a:t>— Then the last step available.  </a:t>
+              <a:t>— Then Dvivida takes his decision.  </a:t>
             </a:r>
             <a:r>
               <a:rPr sz="1550">
@@ -4956,7 +4956,7 @@
                 </a:solidFill>
                 <a:latin typeface="Calibri"/>
               </a:rPr>
-              <a:t>“He killed my best friend; I will get back at him.” Dvivida resolved to destroy Lord Kṛṣṇa's flourishing kingdom.</a:t>
+              <a:t>“He killed my best friend. I am going to get back at him.” And he set out to wreck Kṛṣṇa's flourishing kingdom.</a:t>
             </a:r>
           </a:p>
         </p:txBody>
@@ -5085,7 +5085,7 @@
                 </a:solidFill>
                 <a:latin typeface="Calibri"/>
               </a:rPr>
-              <a:t>The recursion is the point.  </a:t>
+              <a:t>Notice how it passes along.  </a:t>
             </a:r>
             <a:r>
               <a:rPr sz="1400">
@@ -5094,7 +5094,7 @@
                 </a:solidFill>
                 <a:latin typeface="Calibri"/>
               </a:rPr>
-              <a:t>Naraka was corrupted by association; Dvivida was then corrupted by association with Naraka. Corruption propagates — which is why association is treated as a first-order spiritual variable, not a social detail.</a:t>
+              <a:t>Naraka was spoiled by bad association. Then Dvivida was spoiled by associating with Naraka. It spreads — which is why association is treated as a serious spiritual matter and not just a social one.</a:t>
             </a:r>
           </a:p>
         </p:txBody>
@@ -5223,7 +5223,7 @@
                 </a:solidFill>
                 <a:latin typeface="Calibri"/>
               </a:rPr>
-              <a:t>Motive matters for the diagnosis.  </a:t>
+              <a:t>And notice why he does it.  </a:t>
             </a:r>
             <a:r>
               <a:rPr sz="1400">
@@ -5232,7 +5232,7 @@
                 </a:solidFill>
                 <a:latin typeface="Calibri"/>
               </a:rPr>
-              <a:t>The rampage is not appetite or madness. It is revenge — a grievance held on behalf of someone he loved. Revenge is the most self-justifying of the anarthas: it always feels like loyalty.</a:t>
+              <a:t>This is not hunger and it is not madness. It is revenge, for somebody he loved. That is the hardest kind to catch in yourself, because it never feels like a fault. It feels like loyalty.</a:t>
             </a:r>
           </a:p>
         </p:txBody>
@@ -5434,7 +5434,7 @@
                 </a:solidFill>
                 <a:latin typeface="Calibri"/>
               </a:rPr>
-              <a:t>He went for the region around Dvārakā. The Bhāgavatam's inventory of damage is specific, and the specificity is the argument — this is what an unchecked chain of anarthas produces in the world.</a:t>
+              <a:t>He went for the region around Dvārakā. The Bhāgavatam lists the damage one item at a time, and it is worth reading slowly — this is what a chain of unwanted things looks like once nobody is stopping it.</a:t>
             </a:r>
           </a:p>
         </p:txBody>
@@ -5479,7 +5479,7 @@
                 </a:solidFill>
                 <a:latin typeface="Calibri"/>
               </a:rPr>
-              <a:t>— Set fires that burned cities, villages, mines and cowherd dwellings.</a:t>
+              <a:t>— He set fires. Cities burned, villages burned, mines burned, the cowherds' settlements burned.</a:t>
             </a:r>
           </a:p>
           <a:p>
@@ -5501,7 +5501,7 @@
                 </a:solidFill>
                 <a:latin typeface="Calibri"/>
               </a:rPr>
-              <a:t>— Uprooted mountains and hurled them at neighbouring kingdoms — especially Ānarta, where his friend's killer dwelt.</a:t>
+              <a:t>— He pulled up whole mountains and threw them at the neighbouring kingdoms — Ānarta most of all, because that is where Hari lives.</a:t>
             </a:r>
           </a:p>
           <a:p>
@@ -5523,7 +5523,7 @@
                 </a:solidFill>
                 <a:latin typeface="Calibri"/>
               </a:rPr>
-              <a:t>— Entered the ocean and churned its waters with his arms until the coastal regions were submerged.</a:t>
+              <a:t>— He walked into the ocean and churned the water with his arms until the coast went under.</a:t>
             </a:r>
           </a:p>
           <a:p>
@@ -5545,7 +5545,7 @@
                 </a:solidFill>
                 <a:latin typeface="Calibri"/>
               </a:rPr>
-              <a:t>— Tore down the trees of sages' hermitages and contaminated their sacrificial fires with his excrement and urine.</a:t>
+              <a:t>— He tore down the trees around the sages' huts, and fouled their sacrificial fires with his excrement and urine. He wore a belt of skulls.</a:t>
             </a:r>
           </a:p>
           <a:p>
@@ -5567,7 +5567,7 @@
                 </a:solidFill>
                 <a:latin typeface="Calibri"/>
               </a:rPr>
-              <a:t>— Sealed men and women into mountain caves with boulders — “as a wasp imprisons smaller insects.”</a:t>
+              <a:t>— He shut men and women into mountain caves and rolled boulders across the mouths — “as a wasp imprisons smaller insects.”</a:t>
             </a:r>
           </a:p>
           <a:p>
@@ -5589,7 +5589,7 @@
                 </a:solidFill>
                 <a:latin typeface="Calibri"/>
               </a:rPr>
-              <a:t>— Destroyed the kingdom's crops in a huge form at will, and polluted women of respectable families.</a:t>
+              <a:t>— He took an enormous form, looted the crops until people went hungry, and polluted women from respectable families.</a:t>
             </a:r>
           </a:p>
         </p:txBody>
@@ -6097,7 +6097,7 @@
                 </a:solidFill>
                 <a:latin typeface="Calibri"/>
               </a:rPr>
-              <a:t>Hearing sweet singing from Raivataka Mountain, Dvivida went to look. What he found was Balarāma at leisure — and every detail of the scene becomes a target.</a:t>
+              <a:t>He heard sweet singing coming from Raivataka Mountain, so he went to see what it was. What he found was Balarāma enjoying Himself — and every detail of that scene is about to become a target.</a:t>
             </a:r>
           </a:p>
         </p:txBody>
@@ -6363,7 +6363,7 @@
                           </a:solidFill>
                           <a:latin typeface="Calibri"/>
                         </a:rPr>
-                        <a:t>Daughter of King Raivata (Kakudmī), and Balarāma's wife. Among the women present.</a:t>
+                        <a:t>Daughter of King Raivata (Kakudmī), and Balarāma's wife. One of the women there.</a:t>
                       </a:r>
                     </a:p>
                   </a:txBody>
@@ -6390,7 +6390,7 @@
                           </a:solidFill>
                           <a:latin typeface="Calibri"/>
                         </a:rPr>
-                        <a:t>The marriage is why Balarāma is on this mountain at all.</a:t>
+                        <a:t>That marriage is the reason Balarāma is on this mountain in the first place.</a:t>
                       </a:r>
                     </a:p>
                   </a:txBody>
@@ -6446,7 +6446,7 @@
                           </a:solidFill>
                           <a:latin typeface="Calibri"/>
                         </a:rPr>
-                        <a:t>A fragrant beverage. Two chapters earlier Varuṇa arranged for it to collect in a tree hollow to grace Balarāma's dancing.</a:t>
+                        <a:t>A fragrant drink. Two chapters earlier Varuṇa had it collect in a tree hollow so Balarāma could dance.</a:t>
                       </a:r>
                     </a:p>
                   </a:txBody>
@@ -6473,7 +6473,7 @@
                           </a:solidFill>
                           <a:latin typeface="Calibri"/>
                         </a:rPr>
-                        <a:t>The text does not explain how it recurs here. It simply does.</a:t>
+                        <a:t>How it turns up again here is not explained. It just does.</a:t>
                       </a:r>
                     </a:p>
                   </a:txBody>
@@ -6529,7 +6529,7 @@
                           </a:solidFill>
                           <a:latin typeface="Calibri"/>
                         </a:rPr>
-                        <a:t>The fragrant secretion at a bull elephant's temples in rut.</a:t>
+                        <a:t>The scented fluid that runs from a bull elephant's temples when he is in rut.</a:t>
                       </a:r>
                     </a:p>
                   </a:txBody>
@@ -6556,7 +6556,7 @@
                           </a:solidFill>
                           <a:latin typeface="Calibri"/>
                         </a:rPr>
-                        <a:t>The verse's chosen simile for power in an exuberant, unguarded state.</a:t>
+                        <a:t>The verse's own comparison for great strength in a happy, unguarded mood.</a:t>
                       </a:r>
                     </a:p>
                   </a:txBody>
@@ -6612,7 +6612,7 @@
                           </a:solidFill>
                           <a:latin typeface="Calibri"/>
                         </a:rPr>
-                        <a:t>Present — but not in His hands. He is dancing.</a:t>
+                        <a:t>Both there — but not in His hands. He is dancing.</a:t>
                       </a:r>
                     </a:p>
                   </a:txBody>
@@ -6639,7 +6639,7 @@
                           </a:solidFill>
                           <a:latin typeface="Calibri"/>
                         </a:rPr>
-                        <a:t>Their absence is precisely what makes the next scene possible.</a:t>
+                        <a:t>That is exactly what makes the next scene possible.</a:t>
                       </a:r>
                     </a:p>
                   </a:txBody>
@@ -6851,7 +6851,7 @@
                 </a:solidFill>
                 <a:latin typeface="Calibri"/>
               </a:rPr>
-              <a:t>A small masterpiece of characterisation. Dvivida does not attack — he heckles, and each heckle is a rung up.</a:t>
+              <a:t>Watch what he does, because he does not attack. He heckles — and each thing he does is one step worse than the last.</a:t>
             </a:r>
           </a:p>
         </p:txBody>
@@ -6896,7 +6896,7 @@
                 </a:solidFill>
                 <a:latin typeface="Calibri"/>
               </a:rPr>
-              <a:t>— Climbs a branch, shakes the trees, and announces himself with the sound kilakilā.</a:t>
+              <a:t>— He climbs onto a branch, shakes the trees, and makes the sound kilakilā — a gorilla sound.</a:t>
             </a:r>
           </a:p>
           <a:p>
@@ -6918,7 +6918,7 @@
                 </a:solidFill>
                 <a:latin typeface="Calibri"/>
               </a:rPr>
-              <a:t>— Balarāma's consorts laugh at his impudence — young, fond of joking, prone to silliness.</a:t>
+              <a:t>— The girls with Balarāma laugh at his cheek. They are young, they like a joke, they are a little silly.</a:t>
             </a:r>
           </a:p>
           <a:p>
@@ -6940,7 +6940,7 @@
                 </a:solidFill>
                 <a:latin typeface="Calibri"/>
               </a:rPr>
-              <a:t>— Stung at being laughed at, he insults the girls: odd gestures with his eyebrows, walking absurdly, exposing himself and urinating — even as Balarāma looks on.</a:t>
+              <a:t>— Being laughed at is what sets him off. Now he insults the girls — pulling faces with his eyebrows, walking about absurdly, exposing himself and urinating, and all of this while Balarāma is watching him.</a:t>
             </a:r>
           </a:p>
           <a:p>
@@ -6962,7 +6962,7 @@
                 </a:solidFill>
                 <a:latin typeface="Calibri"/>
               </a:rPr>
-              <a:t>— Viśvanātha Cakravartī Ṭhākura adds the sharpest detail: he disrespected Balarāma by not even glancing at Him.</a:t>
+              <a:t>— Viśvanātha Cakravartī Ṭhākura points out the worst part: he did not even glance at Balarāma.</a:t>
             </a:r>
           </a:p>
           <a:p>
@@ -6984,7 +6984,7 @@
                 </a:solidFill>
                 <a:latin typeface="Calibri"/>
               </a:rPr>
-              <a:t>— Balarāma hurls a rock. He dodges it and seizes the pot of vāruṇī.</a:t>
+              <a:t>— Balarāma throws a rock at him. He dodges it and grabs the pot of vāruṇī.</a:t>
             </a:r>
           </a:p>
           <a:p>
@@ -7006,7 +7006,7 @@
                 </a:solidFill>
                 <a:latin typeface="Calibri"/>
               </a:rPr>
-              <a:t>— He breaks the pot, then pulls at the girls' clothing, laughing and ridiculing Him.</a:t>
+              <a:t>— He smashes the pot, then starts pulling at the girls' clothes, laughing at Him the whole time.</a:t>
             </a:r>
           </a:p>
         </p:txBody>
@@ -7135,7 +7135,7 @@
                 </a:solidFill>
                 <a:latin typeface="Calibri"/>
               </a:rPr>
-              <a:t>The detail worth the whole slide.  </a:t>
+              <a:t>The one detail worth this whole slide.  </a:t>
             </a:r>
             <a:r>
               <a:rPr sz="1400">
@@ -7144,7 +7144,7 @@
                 </a:solidFill>
                 <a:latin typeface="Calibri"/>
               </a:rPr>
-              <a:t>Balarāma's first response is a rock — not the club. The commentary explains why: because of Dvivida's previous position as a devotee. Even mid-provocation, the weapon He picks is a statement about memory.</a:t>
+              <a:t>Balarāma's first move is a rock — not His club. The commentary says why: because of Dvivida's previous position as a devotee. Even now, He remembers who this used to be.</a:t>
             </a:r>
           </a:p>
         </p:txBody>
@@ -7273,7 +7273,7 @@
                 </a:solidFill>
                 <a:latin typeface="Calibri"/>
               </a:rPr>
-              <a:t>And the verdict rests elsewhere.  </a:t>
+              <a:t>And this is not what He decides on.  </a:t>
             </a:r>
             <a:r>
               <a:rPr sz="1400">
@@ -7282,7 +7282,7 @@
                 </a:solidFill>
                 <a:latin typeface="Calibri"/>
               </a:rPr>
-              <a:t>Only after seeing the rudeness does Balarāma think of the disruptions in the surrounding kingdoms — and then take up club and plough. He decides on the ravaged province, not the ruined party.</a:t>
+              <a:t>Only after seeing all this rudeness does Balarāma think of the wrecked kingdoms all around — and then He picks up His club and plough. He decides on the ruined province, not the ruined party.</a:t>
             </a:r>
           </a:p>
         </p:txBody>
@@ -7484,7 +7484,7 @@
                 </a:solidFill>
                 <a:latin typeface="Calibri"/>
               </a:rPr>
-              <a:t>A strict escalation in which Dvivida runs out of world to throw while Balarāma steadily discards weapons until He has none left.</a:t>
+              <a:t>Dvivida keeps reaching for something bigger until he runs out of things to throw, while Balarāma keeps putting weapons down until He has none left.</a:t>
             </a:r>
           </a:p>
         </p:txBody>
@@ -7659,7 +7659,7 @@
                 </a:solidFill>
                 <a:latin typeface="Calibri"/>
               </a:rPr>
-              <a:t>Uproots a śāla tree one-handed, strikes His head</a:t>
+              <a:t>Pulls up a śāla tree with one hand and hits Him on the head</a:t>
             </a:r>
           </a:p>
         </p:txBody>
@@ -7750,7 +7750,7 @@
                 </a:solidFill>
                 <a:latin typeface="Calibri"/>
               </a:rPr>
-              <a:t>Stands motionless as a mountain; catches the log</a:t>
+              <a:t>Does not move — stands like a mountain — and catches the tree</a:t>
             </a:r>
           </a:p>
         </p:txBody>
@@ -7841,7 +7841,7 @@
                 </a:solidFill>
                 <a:latin typeface="Calibri"/>
               </a:rPr>
-              <a:t>Ignores the wound; another tree, then another</a:t>
+              <a:t>Does not even notice his own wound. Another tree, then another</a:t>
             </a:r>
           </a:p>
         </p:txBody>
@@ -7932,7 +7932,7 @@
                 </a:solidFill>
                 <a:latin typeface="Calibri"/>
               </a:rPr>
-              <a:t>Strikes his skull with the club Sunanda — “a mountain beautified by red oxide”</a:t>
+              <a:t>Hits his skull with the club Sunanda — “a mountain beautified by streaks of red oxide”</a:t>
             </a:r>
           </a:p>
         </p:txBody>
@@ -8023,7 +8023,7 @@
                 </a:solidFill>
                 <a:latin typeface="Calibri"/>
               </a:rPr>
-              <a:t>Out of trees — releases a rain of stones</a:t>
+              <a:t>No trees left in the forest, so he throws stones</a:t>
             </a:r>
           </a:p>
         </p:txBody>
@@ -8114,7 +8114,7 @@
                 </a:solidFill>
                 <a:latin typeface="Calibri"/>
               </a:rPr>
-              <a:t>Demolishes every tree, then pulverises every stone</a:t>
+              <a:t>Breaks up every tree he throws, then every stone</a:t>
             </a:r>
           </a:p>
         </p:txBody>
@@ -8205,7 +8205,7 @@
                 </a:solidFill>
                 <a:latin typeface="Calibri"/>
               </a:rPr>
-              <a:t>Clenches his fists and beats the Lord's body</a:t>
+              <a:t>Closes his fists and beats on the Lord's body</a:t>
             </a:r>
           </a:p>
         </p:txBody>
@@ -8296,7 +8296,7 @@
                 </a:solidFill>
                 <a:latin typeface="Calibri"/>
               </a:rPr>
-              <a:t>Throws aside club and plough — bare hands against bare hands</a:t>
+              <a:t>Puts club and plough aside — bare hands only, arms like palm trees</a:t>
             </a:r>
           </a:p>
         </p:txBody>
@@ -8387,7 +8387,7 @@
                 </a:solidFill>
                 <a:latin typeface="Calibri"/>
               </a:rPr>
-              <a:t>Collapses, vomiting blood. Raivataka Mountain shakes.</a:t>
+              <a:t>Falls down vomiting blood. The mountain shakes “like a boat tossed about at sea.”</a:t>
             </a:r>
           </a:p>
         </p:txBody>
@@ -8478,7 +8478,7 @@
                 </a:solidFill>
                 <a:latin typeface="Calibri"/>
               </a:rPr>
-              <a:t>A hammering blow to the collarbone</a:t>
+              <a:t>One blow to the collarbone</a:t>
             </a:r>
           </a:p>
         </p:txBody>
@@ -8520,7 +8520,7 @@
                 </a:solidFill>
                 <a:latin typeface="Georgia"/>
               </a:rPr>
-              <a:t>The two columns move in opposite directions. The aggressor climbs tree → stone → fist; the Lord descends club → nothing — and that is when it ends.</a:t>
+              <a:t>The two sides move in opposite directions. He goes tree → stone → fist; the Lord goes club → nothing at all — and that is when it finishes. The demigods called out, “Victory to You! Well done!” and showered flowers.</a:t>
             </a:r>
           </a:p>
           <a:p>
@@ -8539,7 +8539,7 @@
                 </a:solidFill>
                 <a:latin typeface="Calibri"/>
               </a:rPr>
-              <a:t>Afterwards He frees the people sealed in the caves and returns to His capital while the people chant His glories.</a:t>
+              <a:t>Then He let out the people who had been sealed in the caves, and went back to His capital while everyone sang His glories.</a:t>
             </a:r>
           </a:p>
         </p:txBody>
@@ -8741,7 +8741,7 @@
                 </a:solidFill>
                 <a:latin typeface="Calibri"/>
               </a:rPr>
-              <a:t>The chapter closes with a doctrinal point that reframes every death in the Tenth Canto — drawn from SB 2.7, the catalogue of the Lord's scheduled incarnations.</a:t>
+              <a:t>There is one point at the end that changes how you read every killing in the Tenth Canto. It comes from SB 2.7, where the Lord's coming appearances are listed in advance.</a:t>
             </a:r>
           </a:p>
         </p:txBody>
@@ -8980,7 +8980,7 @@
                 </a:solidFill>
                 <a:latin typeface="Calibri"/>
               </a:rPr>
-              <a:t>So the descent was a round trip.  </a:t>
+              <a:t>So he went down, and he came back.  </a:t>
             </a:r>
             <a:r>
               <a:rPr sz="1400">
@@ -8989,7 +8989,7 @@
                 </a:solidFill>
                 <a:latin typeface="Calibri"/>
               </a:rPr>
-              <a:t>The soul who fell from an attendant's position in the Lord's abode is returned to it — by being killed by the Lord.</a:t>
+              <a:t>The soul who lost his place as an attendant in the Lord's abode is put back there — by being killed by the Lord.</a:t>
             </a:r>
           </a:p>
         </p:txBody>
@@ -9127,7 +9127,7 @@
                 </a:solidFill>
                 <a:latin typeface="Calibri"/>
               </a:rPr>
-              <a:t>Let me head off the obvious conclusion at once: you cannot arrange to be an exception — that is what exception means. The mercy shown to Dvivida is a statement about the Lord's nature, not a strategy available to us.</a:t>
+              <a:t>Let me stop the obvious conclusion right here. You cannot arrange to be the exception — that is what exception means. The mercy Dvivida got tells us something about the Lord. It is not a plan any of us can follow.</a:t>
             </a:r>
           </a:p>
         </p:txBody>
@@ -9256,7 +9256,7 @@
                 </a:solidFill>
                 <a:latin typeface="Calibri"/>
               </a:rPr>
-              <a:t>Why He appears at all — BG 4.7–8.  </a:t>
+              <a:t>Why He comes at all — BG 4.7–8.  </a:t>
             </a:r>
             <a:r>
               <a:rPr sz="1400">
@@ -9265,7 +9265,7 @@
                 </a:solidFill>
                 <a:latin typeface="Calibri"/>
               </a:rPr>
-              <a:t>Whenever dharma declines and adharma rises, He descends: to deliver the devotees, annihilate the miscreants, and re-establish dharma, age after age. Balarāma frees the caved-in villagers and kills the ape in the same afternoon.</a:t>
+              <a:t>Whenever religion declines and irreligion rises, He comes: to protect the devotees, finish off the miscreants, and re-establish religion, age after age. Balarāma frees the villagers from the caves and kills the ape on the same afternoon.</a:t>
             </a:r>
           </a:p>
         </p:txBody>
@@ -9467,7 +9467,7 @@
                 </a:solidFill>
                 <a:latin typeface="Calibri"/>
               </a:rPr>
-              <a:t>Garga-saṁhitā's armour-prayer maps each demon Balarāma killed onto the internal enemy He is asked to protect us from. The līlā becomes a prayer, and the prayer becomes a diagnosis.</a:t>
+              <a:t>There is a prayer for protection in the Garga-saṁhitā that takes each demon Balarāma killed and pairs it with an enemy inside us. The pastime becomes a prayer, and the prayer tells you what is wrong with you.</a:t>
             </a:r>
           </a:p>
         </p:txBody>
@@ -9567,7 +9567,7 @@
                           </a:solidFill>
                           <a:latin typeface="Consolas"/>
                         </a:rPr>
-                        <a:t>WHY THE PAIRING WORKS</a:t>
+                        <a:t>WHY THESE GO TOGETHER</a:t>
                       </a:r>
                     </a:p>
                   </a:txBody>
@@ -9650,7 +9650,7 @@
                           </a:solidFill>
                           <a:latin typeface="Calibri"/>
                         </a:rPr>
-                        <a:t>Lust burns like a fire: once lit, it grows on what it consumes.</a:t>
+                        <a:t>Lust burns like a fire. Once it is lit, whatever you feed it makes it bigger.</a:t>
                       </a:r>
                     </a:p>
                   </a:txBody>
@@ -9733,7 +9733,7 @@
                           </a:solidFill>
                           <a:latin typeface="Calibri"/>
                         </a:rPr>
-                        <a:t>Our chapter. Dvivida is driven start to finish by revenge — and once anger takes hold it cannot be stopped from inside.</a:t>
+                        <a:t>Our chapter. Revenge drives Dvivida from beginning to end — and once anger has you, you cannot stop it from inside.</a:t>
                       </a:r>
                     </a:p>
                   </a:txBody>
@@ -9816,7 +9816,7 @@
                           </a:solidFill>
                           <a:latin typeface="Calibri"/>
                         </a:rPr>
-                        <a:t>Balvala contaminated the sacrifices at Naimiṣāraṇya — the appetite that fouls what it feeds on.</a:t>
+                        <a:t>Balvala fouled the sacrifices at Naimiṣāraṇya — the appetite that spoils the thing it feeds on.</a:t>
                       </a:r>
                     </a:p>
                   </a:txBody>
@@ -9899,7 +9899,7 @@
                           </a:solidFill>
                           <a:latin typeface="Calibri"/>
                         </a:rPr>
-                        <a:t>Jarāsandha attacked seventeen times, each time believing the next would work.</a:t>
+                        <a:t>Jarāsandha attacked again and again, believing every time that this time it would work.</a:t>
                       </a:r>
                     </a:p>
                   </a:txBody>
@@ -10038,7 +10038,7 @@
                 </a:solidFill>
                 <a:latin typeface="Calibri"/>
               </a:rPr>
-              <a:t>The move being made here:  </a:t>
+              <a:t>Here is what the prayer is doing:  </a:t>
             </a:r>
             <a:r>
               <a:rPr sz="1400">
@@ -10047,7 +10047,7 @@
                 </a:solidFill>
                 <a:latin typeface="Calibri"/>
               </a:rPr>
-              <a:t>Balarāma's victories are not filed as history. Each is a demonstrated capacity, and the prayer asks Him to exercise that same capacity inside the petitioner. He has defeated anger — visibly, on Raivataka Mountain — so He is the one to ask about yours.</a:t>
+              <a:t>Balarāma's victories are not just old news. Each one shows something He can do, and the prayer asks Him to do that same thing inside you. He has beaten anger — in public, on Raivataka Mountain — so He is the one to ask about yours.</a:t>
             </a:r>
           </a:p>
         </p:txBody>
@@ -10249,7 +10249,7 @@
                 </a:solidFill>
                 <a:latin typeface="Calibri"/>
               </a:rPr>
-              <a:t>A fair question in a chapter where the first offence was something said. I gave four resources, from most structural to most direct.</a:t>
+              <a:t>A fair question to ask in a chapter where the first offence was a sentence somebody said. Here are four things that help.</a:t>
             </a:r>
           </a:p>
         </p:txBody>
@@ -10291,7 +10291,7 @@
                 </a:solidFill>
                 <a:latin typeface="Calibri"/>
               </a:rPr>
-              <a:t>— 1 · Cultivate the mode of goodness.  </a:t>
+              <a:t>— 1 · Build up the mode of goodness.  </a:t>
             </a:r>
             <a:r>
               <a:rPr sz="1450">
@@ -10300,7 +10300,7 @@
                 </a:solidFill>
                 <a:latin typeface="Calibri"/>
               </a:rPr>
-              <a:t>BG 17.15 defines austerity of speech: truthfully, and pleasingly. Both halves are the instruction — and goodness is cultivated by habit (cleanliness, compassion, charity, truthfulness), not summoned on demand.</a:t>
+              <a:t>BG 17.15 says speech should be truthful and pleasing. Both halves are the instruction. And goodness is built by habits — cleanliness, compassion, charity, truthfulness — not switched on when you need it.</a:t>
             </a:r>
           </a:p>
           <a:p>
@@ -10319,7 +10319,7 @@
                 </a:solidFill>
                 <a:latin typeface="Calibri"/>
               </a:rPr>
-              <a:t>— 2 · The tongue has two functions —  </a:t>
+              <a:t>— 2 · The tongue does two jobs —  </a:t>
             </a:r>
             <a:r>
               <a:rPr sz="1450">
@@ -10328,7 +10328,7 @@
                 </a:solidFill>
                 <a:latin typeface="Calibri"/>
               </a:rPr>
-              <a:t>tasting and vibrating. So take only kṛṣṇa-prasādam. Not as rule-following: prasādam spiritualises the tongue, so purity produces control rather than control producing purity.</a:t>
+              <a:t>it tastes and it makes sound. So eat only kṛṣṇa-prasādam. Not as a rule to obey: prasādam purifies the tongue, and then control follows from the purity instead of the other way round.</a:t>
             </a:r>
           </a:p>
           <a:p>
@@ -10347,7 +10347,7 @@
                 </a:solidFill>
                 <a:latin typeface="Calibri"/>
               </a:rPr>
-              <a:t>— 3 · Learn the mechanics of speech.  </a:t>
+              <a:t>— 3 · Learn how to talk to people.  </a:t>
             </a:r>
             <a:r>
               <a:rPr sz="1450">
@@ -10356,7 +10356,7 @@
                 </a:solidFill>
                 <a:latin typeface="Calibri"/>
               </a:rPr>
-              <a:t>Non-violent communication, taught to devotees as empathic communication. Its root insight: understand your own needs and take the steps to meet them; do not require others to. Unmet expectation is what puts the tongue in motion.</a:t>
+              <a:t>Non-violent communication, which devotees are taught as empathic communication. The main idea: know your own needs and take steps to meet them, instead of expecting others to. Unmet expectation is what starts the tongue going.</a:t>
             </a:r>
           </a:p>
           <a:p>
@@ -10375,7 +10375,7 @@
                 </a:solidFill>
                 <a:latin typeface="Calibri"/>
               </a:rPr>
-              <a:t>— 4 · Chanting.  </a:t>
+              <a:t>— 4 · Chant.  </a:t>
             </a:r>
             <a:r>
               <a:rPr sz="1450">
@@ -10384,7 +10384,7 @@
                 </a:solidFill>
                 <a:latin typeface="Calibri"/>
               </a:rPr>
-              <a:t>The ultimate shelter — and the one that occupies both of the tongue's jobs at once.</a:t>
+              <a:t>The best shelter of all — and the only one that uses both of the tongue's jobs at the same time.</a:t>
             </a:r>
           </a:p>
         </p:txBody>
@@ -10513,7 +10513,7 @@
                 </a:solidFill>
                 <a:latin typeface="Calibri"/>
               </a:rPr>
-              <a:t>The trap in half-obeying BG 17.15:  </a:t>
+              <a:t>The trap in obeying only half of BG 17.15:  </a:t>
             </a:r>
             <a:r>
               <a:rPr sz="1400">
@@ -10522,7 +10522,7 @@
                 </a:solidFill>
                 <a:latin typeface="Calibri"/>
               </a:rPr>
-              <a:t>“I just have to speak the truth, because I'm in the mode of goodness.” That is not the mode of goodness. Sattva includes the pleasingly. Truth delivered as a weapon has changed modes without changing content.</a:t>
+              <a:t>“I only have to tell the truth, because I'm in the mode of goodness.” That is not the mode of goodness. Goodness includes the pleasing part. A truth used as a weapon has changed modes without changing a word.</a:t>
             </a:r>
           </a:p>
         </p:txBody>
@@ -10766,7 +10766,7 @@
                 </a:solidFill>
                 <a:latin typeface="Calibri"/>
               </a:rPr>
-              <a:t>— BG 2.62–63, as a practical problem:  </a:t>
+              <a:t>— What BG 2.62–63 is actually describing:  </a:t>
             </a:r>
             <a:r>
               <a:rPr sz="1450">
@@ -10775,7 +10775,7 @@
                 </a:solidFill>
                 <a:latin typeface="Calibri"/>
               </a:rPr>
-              <a:t>from anger comes delusion, from delusion bewilderment of memory, from that the loss of intelligence. The verse describes a system that disables the faculty you would use to interrupt it.</a:t>
+              <a:t>anger produces delusion, delusion makes you forget yourself, and then intelligence is lost. So the thing you would use to stop it is the thing it switches off.</a:t>
             </a:r>
           </a:p>
           <a:p>
@@ -10794,7 +10794,7 @@
                 </a:solidFill>
                 <a:latin typeface="Calibri"/>
               </a:rPr>
-              <a:t>— The proof case — Bhīma and Duryodhana,  </a:t>
+              <a:t>— The example that proves it — Bhīma and Duryodhana,  </a:t>
             </a:r>
             <a:r>
               <a:rPr sz="1450">
@@ -10803,7 +10803,7 @@
                 </a:solidFill>
                 <a:latin typeface="Calibri"/>
               </a:rPr>
-              <a:t>both Balarāma's own students in club-fighting. He came to the battlefield and asked them to stop: Bhīma is stronger, Duryodhana more skilled, neither can win — stop wasting your time.</a:t>
+              <a:t>both of them Balarāma's own students in club-fighting. Their duel went on for days. He travelled there and asked them to stop: Bhīma is stronger, Duryodhana is more skilled, neither of you can win — stop wasting your time.</a:t>
             </a:r>
           </a:p>
           <a:p>
@@ -10831,7 +10831,7 @@
                 </a:solidFill>
                 <a:latin typeface="Calibri"/>
               </a:rPr>
-              <a:t>Not would not — could not. When anger controls you, you cannot hear good advice even from the wisest, dearest person in your life. Even from Balarāma. That is the ceiling on willpower.</a:t>
+              <a:t>Not would not. Could not. When anger is running you, you cannot take good advice even from the wisest, dearest person you know. Not even from Balarāma. That is how far willpower gets you.</a:t>
             </a:r>
           </a:p>
           <a:p>
@@ -10850,7 +10850,7 @@
                 </a:solidFill>
                 <a:latin typeface="Calibri"/>
               </a:rPr>
-              <a:t>— So: change modes, don't fight them.  </a:t>
+              <a:t>— So change the mode instead of fighting it.  </a:t>
             </a:r>
             <a:r>
               <a:rPr sz="1450">
@@ -10859,7 +10859,7 @@
                 </a:solidFill>
                 <a:latin typeface="Calibri"/>
               </a:rPr>
-              <a:t>Anger is ignorance and passion mixed. SB 1.2.24–26 gives the lever — worship of Viṣṇu elevates one to goodness. Give possessions, intelligence, energy, work and its fruits to Him.</a:t>
+              <a:t>Anger is ignorance mixed with passion. SB 1.2 gives the way out — worshipping Viṣṇu raises you to goodness. Give Him your possessions, your intelligence, your energy, your work and what it earns.</a:t>
             </a:r>
           </a:p>
         </p:txBody>
@@ -10988,7 +10988,7 @@
                 </a:solidFill>
                 <a:latin typeface="Calibri"/>
               </a:rPr>
-              <a:t>And then the direct request.  </a:t>
+              <a:t>And then just ask Him.  </a:t>
             </a:r>
             <a:r>
               <a:rPr sz="1400">
@@ -10997,7 +10997,7 @@
                 </a:solidFill>
                 <a:latin typeface="Calibri"/>
               </a:rPr>
-              <a:t>Not self-improvement, but the kavaca: “May Lord Balarāma, who killed Dvivida, always protect me from anger.” He can remove the tendency itself — He has done it before, in public, to the strongest angry being in the chapter. Bhakti is the cure.</a:t>
+              <a:t>Not self-improvement — the kavaca: “May Lord Balarāma, who killed Dvivida, always protect me from anger.” He can take the tendency away. He has done it before, in public, to the angriest and strongest person in the chapter. Bhakti is the cure. And don't get angry at Balarāma.</a:t>
             </a:r>
           </a:p>
         </p:txBody>
@@ -11199,7 +11199,7 @@
                 </a:solidFill>
                 <a:latin typeface="Calibri"/>
               </a:rPr>
-              <a:t>Read at face value: thirty verses of an enormous ape wrecking a coastline until Balarāma punches him to death. Read as its commentators read it: the Bhāgavatam's most precise case study in how a soul who once stood in the Lord's own abode became a demon.</a:t>
+              <a:t>On the surface: thirty verses about a huge ape wrecking a coastline until Balarāma kills him. But the commentators hardly write about the fight. They write about one question — how did a servant of Lord Rāmacandra become a demon?</a:t>
             </a:r>
           </a:p>
         </p:txBody>
@@ -11290,7 +11290,7 @@
                 </a:solidFill>
                 <a:latin typeface="Georgia"/>
               </a:rPr>
-              <a:t>Dvivida did not fall because he was weak. He fell because he was strong, was proud of it, and let that pride slight the Lord's representative.</a:t>
+              <a:t>Dvivida did not fall because he was weak. He fell because he was strong, and proud of it, and that pride made him slight the Lord's representative.</a:t>
             </a:r>
           </a:p>
           <a:p>
@@ -11309,7 +11309,7 @@
                 </a:solidFill>
                 <a:latin typeface="Consolas"/>
               </a:rPr>
-              <a:t>THE THESIS OF THE CHAPTER</a:t>
+              <a:t>THE ONE IDEA</a:t>
             </a:r>
           </a:p>
         </p:txBody>
@@ -11351,7 +11351,7 @@
                 </a:solidFill>
                 <a:latin typeface="Calibri"/>
               </a:rPr>
-              <a:t>— Offence to a devotee  </a:t>
+              <a:t>— Offending a devotee  </a:t>
             </a:r>
             <a:r>
               <a:rPr sz="1500">
@@ -11360,7 +11360,7 @@
                 </a:solidFill>
                 <a:latin typeface="Calibri"/>
               </a:rPr>
-              <a:t>drains spiritual strength.</a:t>
+              <a:t>takes away your spiritual strength.</a:t>
             </a:r>
           </a:p>
           <a:p>
@@ -11379,7 +11379,7 @@
                 </a:solidFill>
                 <a:latin typeface="Calibri"/>
               </a:rPr>
-              <a:t>— Drained of strength,  </a:t>
+              <a:t>— Without that strength,  </a:t>
             </a:r>
             <a:r>
               <a:rPr sz="1500">
@@ -11388,7 +11388,7 @@
                 </a:solidFill>
                 <a:latin typeface="Calibri"/>
               </a:rPr>
-              <a:t>a soul cannot resist bad association.</a:t>
+              <a:t>you cannot resist bad association.</a:t>
             </a:r>
           </a:p>
           <a:p>
@@ -11416,7 +11416,7 @@
                 </a:solidFill>
                 <a:latin typeface="Calibri"/>
               </a:rPr>
-              <a:t>breeds anarthas — unwanted, obstructive things.</a:t>
+              <a:t>gives you anarthas — unwanted things, in the way.</a:t>
             </a:r>
           </a:p>
           <a:p>
@@ -11444,7 +11444,7 @@
                 </a:solidFill>
                 <a:latin typeface="Calibri"/>
               </a:rPr>
-              <a:t>breed further offence, without a floor.</a:t>
+              <a:t>bring more offences. This loop has no bottom.</a:t>
             </a:r>
           </a:p>
         </p:txBody>
@@ -11573,7 +11573,7 @@
                 </a:solidFill>
                 <a:latin typeface="Calibri"/>
               </a:rPr>
-              <a:t>The frame vs. the content.  </a:t>
+              <a:t>So what is the chapter about?  </a:t>
             </a:r>
             <a:r>
               <a:rPr sz="1400">
@@ -11582,7 +11582,7 @@
                 </a:solidFill>
                 <a:latin typeface="Calibri"/>
               </a:rPr>
-              <a:t>The fight is the frame. That chain is the content.</a:t>
+              <a:t>The fight is only the setting. That chain is the chapter.</a:t>
             </a:r>
           </a:p>
         </p:txBody>
@@ -11784,7 +11784,7 @@
                 </a:solidFill>
                 <a:latin typeface="Calibri"/>
               </a:rPr>
-              <a:t>We read this on Balarāma-pūrṇimā, so let me close where the chapter closes — not with the ape but with the two brothers in Vṛndāvana, and with something practical to do about the anger, the pride and the offences.</a:t>
+              <a:t>We are reading this on Balarāma-pūrṇimā, so let me finish where the chapter finishes — not with the ape, but with the two brothers, and with something you can actually do about the anger, the pride and the offences.</a:t>
             </a:r>
           </a:p>
         </p:txBody>
@@ -11826,7 +11826,7 @@
                 </a:solidFill>
                 <a:latin typeface="Calibri"/>
               </a:rPr>
-              <a:t>— Śrīla Prabhupāda, asked on a morning walk  </a:t>
+              <a:t>— Śrīla Prabhupāda was asked on a morning walk  </a:t>
             </a:r>
             <a:r>
               <a:rPr sz="1450">
@@ -11835,7 +11835,7 @@
                 </a:solidFill>
                 <a:latin typeface="Calibri"/>
               </a:rPr>
-              <a:t>what to do about an obstacle you cannot overcome: go before the deity — of Gaurāṅga, or of Kṛṣṇa-Balarāma, they are non-different — and say, “Sir, I have a problem. Please help me.” And he will do the needful.</a:t>
+              <a:t>what to do about an obstacle you cannot get past. Go and stand before the deity — Gaurāṅga, or Kṛṣṇa-Balarāma, they are not different — and say, “Sir, I have a problem. Please help me.” And he will do the needful.</a:t>
             </a:r>
           </a:p>
           <a:p>
@@ -11854,7 +11854,7 @@
                 </a:solidFill>
                 <a:latin typeface="Calibri"/>
               </a:rPr>
-              <a:t>— Two qualifications he attached.  </a:t>
+              <a:t>— He added two things.  </a:t>
             </a:r>
             <a:r>
               <a:rPr sz="1450">
@@ -11863,7 +11863,7 @@
                 </a:solidFill>
                 <a:latin typeface="Calibri"/>
               </a:rPr>
-              <a:t>Not because the Lord is an order-supplier — that is not the relationship. But because He is merciful to one who depends on Him as a child depends on a parent. And: don't make it too much your business to bother Him too many times.</a:t>
+              <a:t>Not because the Lord is there to supply your orders — that is not the relationship. But because He is kind to someone who depends on Him the way a child depends on a parent. And: don't make a habit of bothering Him too many times.</a:t>
             </a:r>
           </a:p>
           <a:p>
@@ -11882,7 +11882,7 @@
                 </a:solidFill>
                 <a:latin typeface="Calibri"/>
               </a:rPr>
-              <a:t>— A confirmation from the room.  </a:t>
+              <a:t>— Somebody in the room confirmed it.  </a:t>
             </a:r>
             <a:r>
               <a:rPr sz="1450">
@@ -11891,7 +11891,7 @@
                 </a:solidFill>
                 <a:latin typeface="Calibri"/>
               </a:rPr>
-              <a:t>A devotee said they pray exactly like that, and that it is true — not instantaneously, but it works. When something is genuinely required, you know where to go.</a:t>
+              <a:t>A devotee said they pray exactly like that, and it works — not instantaneously, but it works. When you really need something, you know where to go.</a:t>
             </a:r>
           </a:p>
         </p:txBody>
@@ -12020,7 +12020,7 @@
                 </a:solidFill>
                 <a:latin typeface="Calibri"/>
               </a:rPr>
-              <a:t>A good combination to have on your side:  </a:t>
+              <a:t>That is a good pair to have on your side:  </a:t>
             </a:r>
             <a:r>
               <a:rPr sz="1400">
@@ -12186,7 +12186,7 @@
                 </a:solidFill>
                 <a:latin typeface="Georgia"/>
               </a:rPr>
-              <a:t>Find the last rung you actually control.</a:t>
+              <a:t>Find the last step you can still do something about.</a:t>
             </a:r>
           </a:p>
           <a:p>
@@ -12208,7 +12208,7 @@
                 </a:solidFill>
                 <a:latin typeface="Georgia"/>
               </a:rPr>
-              <a:t>It is not bad association — by then the outcome is largely written. It is pride, and specifically the habit of measuring devotees against yourself.</a:t>
+              <a:t>It is not bad association — by the time you are there, most of it is already decided. It is pride: the habit of measuring devotees against yourself.</a:t>
             </a:r>
           </a:p>
         </p:txBody>
@@ -12338,7 +12338,7 @@
                 </a:solidFill>
                 <a:latin typeface="Calibri"/>
               </a:rPr>
-              <a:t>Śrīmad-Bhāgavatam 10.67 with 10.2, 10.59, 10.65, 10.66, 2.7.34–35, 1.2.24–26 · Bhagavad-gītā 2.62–63, 4.7–8, 17.15 · Vālmīki Rāmāyaṇa (Kiṣkindhā- and Uttara-kāṇḍa) · Viśvanātha Cakravartī Ṭhākura on SB 10.67 · Jīva Gosvāmī, Bhakti-sandarbha, his SB commentary and Gopāla-campū · Garga-saṁhitā · Bhaktivinoda Ṭhākura, Caitanya-śikṣāmṛta and Kṛṣṇa-saṁhitā.</a:t>
+              <a:t>Śrīmad-Bhāgavatam 10.67 with 10.2, 10.59, 10.65, 10.66, 2.7.34–35, 1.2 · Bhagavad-gītā 2.62–63, 4.7–8, 17.15 · Vālmīki Rāmāyaṇa (Kiṣkindhā- and Uttara-kāṇḍa) · Viśvanātha Cakravartī Ṭhākura on SB 10.67 · Jīva Gosvāmī, Bhakti-sandarbha, his SB commentary and Gopāla-campū · Garga-saṁhitā · Bhaktivinoda Ṭhākura, Caitanya-śikṣāmṛta and Kṛṣṇa-saṁhitā.</a:t>
             </a:r>
           </a:p>
           <a:p>
@@ -12559,7 +12559,7 @@
                 </a:solidFill>
                 <a:latin typeface="Calibri"/>
               </a:rPr>
-              <a:t>Every Bhāgavatam chapter answers a question someone actually asked. Here the questioner is Mahārāja Parīkṣit — a king with seven days left to live and no time for decoration.</a:t>
+              <a:t>Every chapter of the Bhāgavatam answers a question somebody actually asked. Here the person asking is Mahārāja Parīkṣit. He has seven days left to live, so he does not waste words.</a:t>
             </a:r>
           </a:p>
         </p:txBody>
@@ -12825,7 +12825,7 @@
                           </a:solidFill>
                           <a:latin typeface="Calibri"/>
                         </a:rPr>
-                        <a:t>Balarāma visits Vṛndāvana; dances with the gopīs, drinks vāruṇī, drags the Yamunā off course with His plough.</a:t>
+                        <a:t>Balarāma visits Vṛndāvana after a long time away. He dances with the gopīs, drinks vāruṇī, and drags the Yamunā off her course with His plough.</a:t>
                       </a:r>
                     </a:p>
                   </a:txBody>
@@ -12852,7 +12852,7 @@
                           </a:solidFill>
                           <a:latin typeface="Calibri"/>
                         </a:rPr>
-                        <a:t>Establishes the exact scene Chapter 67 repeats. Dvivida walks into a setting we have already been shown.</a:t>
+                        <a:t>This is the same scene chapter 67 repeats. Dvivida walks into a scene we have already been shown.</a:t>
                       </a:r>
                     </a:p>
                   </a:txBody>
@@ -12908,7 +12908,7 @@
                           </a:solidFill>
                           <a:latin typeface="Calibri"/>
                         </a:rPr>
-                        <a:t>Kṛṣṇa kills Pauṇḍraka, the impostor who dressed as Viṣṇu.</a:t>
+                        <a:t>Kṛṣṇa kills Pauṇḍraka, the impostor who dressed as Viṣṇu and told Kṛṣṇa to hand over the insignia.</a:t>
                       </a:r>
                     </a:p>
                   </a:txBody>
@@ -12935,7 +12935,7 @@
                           </a:solidFill>
                           <a:latin typeface="Calibri"/>
                         </a:rPr>
-                        <a:t>Balarāma is still in Vṛndāvana — so Parīkṣit gets no Balarāma news, hence his renewed request.</a:t>
+                        <a:t>Balarāma is still in Vṛndāvana, so Parīkṣit hears nothing about Him — which is why he asks again in 67.1.</a:t>
                       </a:r>
                     </a:p>
                   </a:txBody>
@@ -12991,7 +12991,7 @@
                           </a:solidFill>
                           <a:latin typeface="Calibri"/>
                         </a:rPr>
-                        <a:t>Eight chapters earlier: Kṛṣṇa kills Narakāsura, freeing 16,100 princesses.</a:t>
+                        <a:t>Eight chapters earlier: Kṛṣṇa kills Narakāsura and frees 16,100 imprisoned princesses.</a:t>
                       </a:r>
                     </a:p>
                   </a:txBody>
@@ -13018,7 +13018,7 @@
                           </a:solidFill>
                           <a:latin typeface="Calibri"/>
                         </a:rPr>
-                        <a:t>The death that gives Dvivida his motive. He is not a random monster — he is a friend avenging a friend.</a:t>
+                        <a:t>This is the death that gives Dvivida his motive. He is not a random monster. He is a friend taking revenge for a friend.</a:t>
                       </a:r>
                     </a:p>
                   </a:txBody>
@@ -13230,7 +13230,7 @@
                 </a:solidFill>
                 <a:latin typeface="Calibri"/>
               </a:rPr>
-              <a:t>Dvivida serves under Sugrīva in Rāmacandra's pastimes and dies in Kṛṣṇa's. If those advents are far apart, the chapter's first factual claim is really a claim about his longevity.</a:t>
+              <a:t>Dvivida serves Sugrīva in Rāmacandra's pastimes and dies during Kṛṣṇa's. So if those two appearances are far apart, the chapter's first fact about him turns out to be a fact about his lifespan.</a:t>
             </a:r>
           </a:p>
         </p:txBody>
@@ -14240,7 +14240,7 @@
                 </a:solidFill>
                 <a:latin typeface="Calibri"/>
               </a:rPr>
-              <a:t>Dvivida is alive across this entire span — ≈4 yuga-cycles, tens of millions of years.</a:t>
+              <a:t>Dvivida is alive through all of this — about 4 yuga-cycles, tens of millions of years.</a:t>
             </a:r>
           </a:p>
           <a:p>
@@ -14599,7 +14599,7 @@
                 </a:solidFill>
                 <a:latin typeface="Calibri"/>
               </a:rPr>
-              <a:t>Dvivida was not made to be a demon. He was manufactured, deliberately, to help the Lord.</a:t>
+              <a:t>Dvivida was not born a demon. He was born on purpose, to help the Lord.</a:t>
             </a:r>
           </a:p>
         </p:txBody>
@@ -14650,7 +14650,7 @@
                 </a:solidFill>
                 <a:latin typeface="Calibri"/>
               </a:rPr>
-              <a:t>Rāvaṇa held benedictions from Brahmā making him unkillable by whole categories of being — but he never thought to exclude animals. Viṣṇu told the demigods to father offspring in the categories the benedictions missed.</a:t>
+              <a:t>Rāvaṇa had asked Brahmā to make him unkillable by demigods, demons, snakes and the rest — and forgot to mention animals. So Viṣṇu told the demigods: have sons in the shapes he left out.</a:t>
             </a:r>
           </a:p>
           <a:p>
@@ -14669,7 +14669,7 @@
                 </a:solidFill>
                 <a:latin typeface="Calibri"/>
               </a:rPr>
-              <a:t>— So the demigods fathered vānaras.  </a:t>
+              <a:t>— That is why the demigods fathered monkeys.  </a:t>
             </a:r>
             <a:r>
               <a:rPr sz="1500">
@@ -14678,7 +14678,7 @@
                 </a:solidFill>
                 <a:latin typeface="Calibri"/>
               </a:rPr>
-              <a:t>The Aśvinī-kumāras produced two sons: Mainda and Dvivida, brothers, ministers in the court of the monkey-king Sugrīva.</a:t>
+              <a:t>The Aśvinī-kumāras had two sons, Mainda and Dvivida. Brothers. Both became ministers to Sugrīva, the monkey king.</a:t>
             </a:r>
           </a:p>
           <a:p>
@@ -14697,7 +14697,7 @@
                 </a:solidFill>
                 <a:latin typeface="Calibri"/>
               </a:rPr>
-              <a:t>— Service in the search for Sītā.  </a:t>
+              <a:t>— They helped look for Sītā.  </a:t>
             </a:r>
             <a:r>
               <a:rPr sz="1500">
@@ -14706,7 +14706,7 @@
                 </a:solidFill>
                 <a:latin typeface="Calibri"/>
               </a:rPr>
-              <a:t>Both went south with Aṅgada's party of thirty thousand — Hanumān among them — the group that Sampāti, Jaṭāyu's grounded brother, finally pointed to the Aśoka grove in Laṅkā.</a:t>
+              <a:t>Both went south with Aṅgada's party of thirty thousand monkeys, Hanumān among them — the party that Sampāti, Jaṭāyu's elder brother, finally sent to the Aśoka grove in Laṅkā.</a:t>
             </a:r>
           </a:p>
           <a:p>
@@ -14725,7 +14725,7 @@
                 </a:solidFill>
                 <a:latin typeface="Calibri"/>
               </a:rPr>
-              <a:t>— One of the five who remained.  </a:t>
+              <a:t>— And he was one of the five asked to stay.  </a:t>
             </a:r>
             <a:r>
               <a:rPr sz="1500">
@@ -14734,7 +14734,7 @@
                 </a:solidFill>
                 <a:latin typeface="Calibri"/>
               </a:rPr>
-              <a:t>Before Rāmacandra entered the Sarayū, He designated five devotees to stay behind: Hanumān, Jāmbavān, Vibhīṣaṇa, Mainda — and Dvivida.</a:t>
+              <a:t>Before Rāmacandra walked into the Sarayū river, He named five devotees who were to remain: Hanumān, Jāmbavān, Vibhīṣaṇa, Mainda — and Dvivida.</a:t>
             </a:r>
           </a:p>
         </p:txBody>
@@ -14863,7 +14863,7 @@
                 </a:solidFill>
                 <a:latin typeface="Calibri"/>
               </a:rPr>
-              <a:t>This is the fact the chapter turns on.  </a:t>
+              <a:t>This is the fact the whole chapter turns on.  </a:t>
             </a:r>
             <a:r>
               <a:rPr sz="1400">
@@ -14872,7 +14872,7 @@
                 </a:solidFill>
                 <a:latin typeface="Calibri"/>
               </a:rPr>
-              <a:t>Dvivida was hand-picked by the Lord Himself to stay. Whatever happens next happens to someone the Lord chose — which is why “could it happen to me?” is not a rhetorical question.</a:t>
+              <a:t>The Lord Himself picked him to stay. So everything that happens next happens to someone the Lord chose — which is why “could this happen to me?” is a real question, not a rhetorical one.</a:t>
             </a:r>
           </a:p>
         </p:txBody>
@@ -15074,7 +15074,7 @@
                 </a:solidFill>
                 <a:latin typeface="Calibri"/>
               </a:rPr>
-              <a:t>The Bhāgavatam does not call him strong; it quantifies him twice. His strength is the raw material of his pride, and his pride is the first link in the chain.</a:t>
+              <a:t>The Bhāgavatam does not just say he was strong. It gives numbers, twice. That strength is what his pride was made of, and the pride is the first link in the chain.</a:t>
             </a:r>
           </a:p>
         </p:txBody>
@@ -15628,7 +15628,7 @@
                 </a:solidFill>
                 <a:latin typeface="Consolas"/>
               </a:rPr>
-              <a:t>70 yojanas · 560 mi — “I can undoubtedly jump further”</a:t>
+              <a:t>70 yojanas · 560 mi — “Mainda was not as strong as me”</a:t>
             </a:r>
           </a:p>
         </p:txBody>
@@ -15756,7 +15756,7 @@
                 </a:solidFill>
                 <a:latin typeface="Consolas"/>
               </a:rPr>
-              <a:t>the whole crossing — and back. The only one who did not boast.</a:t>
+              <a:t>“a hundred yojanas — and back again.” The only one who did not compare himself.</a:t>
             </a:r>
           </a:p>
         </p:txBody>
@@ -15885,7 +15885,7 @@
                 </a:solidFill>
                 <a:latin typeface="Calibri"/>
               </a:rPr>
-              <a:t>The tell is in the phrasing.  </a:t>
+              <a:t>Listen to how they say it.  </a:t>
             </a:r>
             <a:r>
               <a:rPr sz="1400">
@@ -15894,7 +15894,7 @@
                 </a:solidFill>
                 <a:latin typeface="Calibri"/>
               </a:rPr>
-              <a:t>Mainda says what he can do. Dvivida says what he can do more than Mainda. Comparison is where bala quietly becomes bala-abhimāna — strength becoming pride in strength.</a:t>
+              <a:t>Mainda says what he can do. Dvivida says he can do more than Mainda. That comparison is the moment strength turns into pride in strength — bala into bala-abhimāna.</a:t>
             </a:r>
           </a:p>
         </p:txBody>
@@ -16023,7 +16023,7 @@
                 </a:solidFill>
                 <a:latin typeface="Calibri"/>
               </a:rPr>
-              <a:t>The second figure —  </a:t>
+              <a:t>The second number —  </a:t>
             </a:r>
             <a:r>
               <a:rPr sz="1400">
@@ -16032,7 +16032,7 @@
                 </a:solidFill>
                 <a:latin typeface="Calibri"/>
               </a:rPr>
-              <a:t>by Chapter 67 he churns the ocean with the strength of ten thousand elephants, uproots mountains, and tears down śāla hardwood one-handed. SB 10.2 already lists him among the demons available to Kaṁsa.</a:t>
+              <a:t>by this chapter he churns the ocean with the strength of ten thousand elephants, pulls up mountains, and rips down śāla hardwood with one hand. SB 10.2 already lists him among the demons Kaṁsa could call on.</a:t>
             </a:r>
           </a:p>
         </p:txBody>
@@ -16234,7 +16234,7 @@
                 </a:solidFill>
                 <a:latin typeface="Calibri"/>
               </a:rPr>
-              <a:t>The commentators state that Mainda and Dvivida are eternally liberated — attendant deities in the worship of Rāmacandra. But souls in the Lord's abode do not fall. So what happened?</a:t>
+              <a:t>The commentaries say Mainda and Dvivida are eternally liberated — attendants worshipped along with Rāmacandra. But souls in the Lord's abode don't fall down. So what happened here?</a:t>
             </a:r>
           </a:p>
         </p:txBody>
@@ -16285,7 +16285,7 @@
                 </a:solidFill>
                 <a:latin typeface="Calibri"/>
               </a:rPr>
-              <a:t>they are worshipped as āvaraṇa-devatās — “covered” attendant deities, situated in the Lord's abode as part of His retinue, not displaying Viṣṇu's fullness themselves.</a:t>
+              <a:t>they are worshipped as āvaraṇa-devatās — attendants who surround the Lord and belong to His entourage, without showing Viṣṇu's own fullness.</a:t>
             </a:r>
           </a:p>
           <a:p>
@@ -16304,7 +16304,7 @@
                 </a:solidFill>
                 <a:latin typeface="Calibri"/>
               </a:rPr>
-              <a:t>— Jīva Gosvāmī on this chapter:  </a:t>
+              <a:t>— Jīva Gosvāmī on this very chapter:  </a:t>
             </a:r>
             <a:r>
               <a:rPr sz="1450">
@@ -16332,7 +16332,7 @@
                 </a:solidFill>
                 <a:latin typeface="Calibri"/>
               </a:rPr>
-              <a:t>— The finer distinction:  </a:t>
+              <a:t>— The distinction that resolves it:  </a:t>
             </a:r>
             <a:r>
               <a:rPr sz="1450">
@@ -16341,7 +16341,7 @@
                 </a:solidFill>
                 <a:latin typeface="Calibri"/>
               </a:rPr>
-              <a:t>some jīvas are endowed with a portion of an eternal associate's śakti and bear the same name. Such jīvas can be corrupted — because they are jīvas.</a:t>
+              <a:t>some jīvas are given a portion of an eternal associate's power and carry the same name. Those jīvas can be corrupted, because they are still jīvas.</a:t>
             </a:r>
           </a:p>
           <a:p>
@@ -16498,7 +16498,7 @@
                 </a:solidFill>
                 <a:latin typeface="Calibri"/>
               </a:rPr>
-              <a:t>Do not generalise this.  </a:t>
+              <a:t>Please don't turn this into a general theory.  </a:t>
             </a:r>
             <a:r>
               <a:rPr sz="1400">
@@ -16507,7 +16507,7 @@
                 </a:solidFill>
                 <a:latin typeface="Calibri"/>
               </a:rPr>
-              <a:t>The souls in this world were not once residents of Vaikuṇṭha who fell. Jaya and Vijaya are an exception arranged for instruction, and so is Dvivida — “it's the exception, not the rule.” Take the lesson; don't take it as a theory of where you came from.</a:t>
+              <a:t>We were not all once living in Vaikuṇṭha and then fell. Jaya and Vijaya were an exception arranged to teach us something, and so is Dvivida — “it's the exception, it's not the rule.” Take the lesson, not a theory about where you came from.</a:t>
             </a:r>
           </a:p>
         </p:txBody>
@@ -16709,7 +16709,7 @@
                 </a:solidFill>
                 <a:latin typeface="Calibri"/>
               </a:rPr>
-              <a:t>The offence is not pride itself. Pride is the condition. The offence is what pride produced — and there are two, both against Lakṣmaṇa, both easy to miss in the Rāmāyaṇa.</a:t>
+              <a:t>Pride by itself was not the offence. Pride was the condition he was in. The offences are what the pride made him say and think — two of them, both about Lakṣmaṇa, both easy to read past in the Rāmāyaṇa.</a:t>
             </a:r>
           </a:p>
         </p:txBody>
@@ -16861,7 +16861,7 @@
                 </a:solidFill>
                 <a:latin typeface="Calibri"/>
               </a:rPr>
-              <a:t>Said to Sugrīva, during the introduction, while rendering service.</a:t>
+              <a:t>Said to Sugrīva while introducing him to Rāma — while doing service, and meaning well.</a:t>
             </a:r>
           </a:p>
         </p:txBody>
@@ -17013,7 +17013,7 @@
                 </a:solidFill>
                 <a:latin typeface="Calibri"/>
               </a:rPr>
-              <a:t>Thought — not spoken — of Lakṣmaṇa lying in great pain, struck down by the śakti weapon.</a:t>
+              <a:t>Thought, not said. Lakṣmaṇa was lying in great pain, hit by the śakti weapon. Nobody heard this.</a:t>
             </a:r>
           </a:p>
         </p:txBody>
@@ -17142,7 +17142,7 @@
                 </a:solidFill>
                 <a:latin typeface="Calibri"/>
               </a:rPr>
-              <a:t>Neither was hostile, and neither was heard.  </a:t>
+              <a:t>Neither one was hostile. Neither one was heard.  </a:t>
             </a:r>
             <a:r>
               <a:rPr sz="1400">
@@ -17151,7 +17151,7 @@
                 </a:solidFill>
                 <a:latin typeface="Calibri"/>
               </a:rPr>
-              <a:t>One was well-meant advice; the other was a private thought. Both counted. Vaiṣṇava-aparādha does not require malice, volume, or an audience.</a:t>
+              <a:t>The first was friendly advice. The second was a private thought. Both still counted. Offending a devotee does not need anger, volume, or an audience.</a:t>
             </a:r>
           </a:p>
         </p:txBody>
@@ -17280,7 +17280,7 @@
                 </a:solidFill>
                 <a:latin typeface="Calibri"/>
               </a:rPr>
-              <a:t>Both share one root.  </a:t>
+              <a:t>Both come from the same place.  </a:t>
             </a:r>
             <a:r>
               <a:rPr sz="1400">
@@ -17289,7 +17289,7 @@
                 </a:solidFill>
                 <a:latin typeface="Calibri"/>
               </a:rPr>
-              <a:t>He measured Lakṣmaṇa against himself — low on importance, then low on heroism. Pride is not a feeling; it is a measuring instrument pointed the wrong way.</a:t>
+              <a:t>He measured Lakṣmaṇa against himself — first not important enough, then not heroic enough. That is what pride actually does: it makes you the yardstick.</a:t>
             </a:r>
           </a:p>
         </p:txBody>
@@ -17491,7 +17491,7 @@
                 </a:solidFill>
                 <a:latin typeface="Calibri"/>
               </a:rPr>
-              <a:t>Shortened to “don't offend Lakṣmaṇa,” the warning invites the wrong reply: fine, but I'm unlikely to meet him. Lakṣmaṇa matters here as an instance of a category.</a:t>
+              <a:t>If we shorten this to “don't offend Lakṣmaṇa,” it is easy to answer: fine, I'm not likely to meet him. But Lakṣmaṇa is here as an example of something much wider.</a:t>
             </a:r>
           </a:p>
         </p:txBody>
@@ -17582,7 +17582,7 @@
                 </a:solidFill>
                 <a:latin typeface="Georgia"/>
               </a:rPr>
-              <a:t>Guru-tattva — the principle of the Lord's representative: the one who introduces the Supreme Lord, gives instruction, and gives association. Lakṣmaṇa holds this position to Rāma exactly as Balarāma does to Kṛṣṇa, and as Nanda Mahārāja does.</a:t>
+              <a:t>Guru-tattva — the Lord's representative. The one who introduces you to the Supreme Lord, instructs you, and gives you His association. Lakṣmaṇa is that to Rāma. Balarāma is that to Kṛṣṇa. So is Nanda Mahārāja.</a:t>
             </a:r>
           </a:p>
           <a:p>
@@ -17643,7 +17643,7 @@
                 </a:solidFill>
                 <a:latin typeface="Calibri"/>
               </a:rPr>
-              <a:t>— The shape of the offence:  </a:t>
+              <a:t>— What he actually did:  </a:t>
             </a:r>
             <a:r>
               <a:rPr sz="1600">
@@ -17652,7 +17652,7 @@
                 </a:solidFill>
                 <a:latin typeface="Calibri"/>
               </a:rPr>
-              <a:t>he directed attention to the Lord while deprecating the one making the introduction possible. He kept the object of devotion and discarded the channel.</a:t>
+              <a:t>he pointed everyone towards the Lord and put down the person who was making that introduction possible. He kept the Lord and threw away the connection to Him.</a:t>
             </a:r>
           </a:p>
           <a:p>
@@ -17671,7 +17671,7 @@
                 </a:solidFill>
                 <a:latin typeface="Calibri"/>
               </a:rPr>
-              <a:t>— The symmetry:  </a:t>
+              <a:t>— And look how it comes back:  </a:t>
             </a:r>
             <a:r>
               <a:rPr sz="1600">
@@ -17680,7 +17680,7 @@
                 </a:solidFill>
                 <a:latin typeface="Calibri"/>
               </a:rPr>
-              <a:t>he offends the guru-tattva in Rāma's pastimes and is killed by the guru-tattva in Kṛṣṇa's. Across yugas, he is dealt with by the very principle he slighted.</a:t>
+              <a:t>he offends the guru-tattva in Rāma's pastimes, and is killed by the guru-tattva in Kṛṣṇa's. Yugas later, the same principle he brushed aside is the one that deals with him.</a:t>
             </a:r>
           </a:p>
         </p:txBody>
@@ -17809,7 +17809,7 @@
                 </a:solidFill>
                 <a:latin typeface="Calibri"/>
               </a:rPr>
-              <a:t>The generalisation I want to insist on:  </a:t>
+              <a:t>The point I want to insist on:  </a:t>
             </a:r>
             <a:r>
               <a:rPr sz="1400">
@@ -17818,7 +17818,7 @@
                 </a:solidFill>
                 <a:latin typeface="Calibri"/>
               </a:rPr>
-              <a:t>“It's not just that you're not Lakṣmaṇa, so I can mess with you.” The principle is vaiṣṇava-aparādha — offence to any devotee — and one can lose one's spiritual standing as its consequence.</a:t>
+              <a:t>“It's not just that you're not Lakṣmaṇa, so I can mess with you.” The principle is vaiṣṇava-aparādha — offending any devotee — and you can lose your spiritual standing over it.</a:t>
             </a:r>
           </a:p>
         </p:txBody>

</xml_diff>